<commit_message>
Netralkan framing Termin 1 di paket laporan LGU
Status Termin 1 sekarang disajikan per syarat kontraktual tanpa vonis
"Belum" atau "Layak" dari tim - penilaian pemenuhan dan keputusan
pembayaran adalah evaluasi Pertamina. Berlaku di laporan utama
(KPI, ringkasan, bagian 4, tabel risiko) dan slide rapat 29 September.

Co-Authored-By: Claude Opus 5.5 <noreply@anthropic.com>
</commit_message>
<xml_diff>
--- a/Deliverables/Presentasi_Rapat_Koordinasi_Instalasi_29September2026.pptx
+++ b/Deliverables/Presentasi_Rapat_Koordinasi_Instalasi_29September2026.pptx
@@ -3308,7 +3308,7 @@
                 <a:ea typeface="Calibri" pitchFamily="34" charset="-122"/>
                 <a:cs typeface="Calibri" pitchFamily="34" charset="-120"/>
               </a:rPr>
-              <a:t>Termin 1 — Field Testing</a:t>
+              <a:t>Dokumen Termin 1 — Field Testing</a:t>
             </a:r>
             <a:endParaRPr lang="en-US" sz="1300" dirty="0"/>
           </a:p>
@@ -3463,7 +3463,7 @@
                 <a:ea typeface="Calibri" pitchFamily="34" charset="-122"/>
                 <a:cs typeface="Calibri" pitchFamily="34" charset="-120"/>
               </a:rPr>
-              <a:t>dinilai layak diajukan (20% syarat kontraktual)</a:t>
+              <a:t>laporan pemenuhan &amp; draf BAST lengkap; evaluasi oleh Pertamina</a:t>
             </a:r>
             <a:endParaRPr lang="en-US" sz="1050" dirty="0"/>
           </a:p>

</xml_diff>